<commit_message>
Unifica el fondo de las fotos del equipo
Co-Authored-By: Claude Opus 5.5 <noreply@anthropic.com>
Claude-Session: https://claude.ai/code/session_018mufWPZrGGp9c32gWXHPYT
</commit_message>
<xml_diff>
--- a/files/Accountability_TALENT.pptx
+++ b/files/Accountability_TALENT.pptx
@@ -118,19 +118,19 @@
   <p:extLst>
     <p:ext uri="{521415D9-36F7-43E2-AB2F-B90AF26B5E84}">
       <p14:sectionLst xmlns:p14="http://schemas.microsoft.com/office/powerpoint/2010/main">
-        <p14:section name="Equipo y unidad de análisis" id="{638adc67-8009-c8e4-9a1f-a05eda1996c6}">
+        <p14:section name="Equipo y unidad de análisis" id="{11f0a217-c063-aa25-f0dc-fe1dc68fc88d}">
           <p14:sldIdLst>
             <p14:sldId id="256"/>
             <p14:sldId id="257"/>
             <p14:sldId id="258"/>
           </p14:sldIdLst>
         </p14:section>
-        <p14:section name="Modelo de negocio" id="{77b76efe-206f-9b30-09c6-4cd37ca21815}">
+        <p14:section name="Modelo de negocio" id="{9a7c011b-9842-55b8-b787-fe24b91fee32}">
           <p14:sldIdLst>
             <p14:sldId id="259"/>
           </p14:sldIdLst>
         </p14:section>
-        <p14:section name="Diagnóstico" id="{26e27577-5332-90d3-4e40-41b248165d9d}">
+        <p14:section name="Diagnóstico" id="{8bf727aa-2af1-93ab-b015-cbebfc5de34c}">
           <p14:sldIdLst>
             <p14:sldId id="260"/>
             <p14:sldId id="261"/>
@@ -138,7 +138,7 @@
             <p14:sldId id="263"/>
           </p14:sldIdLst>
         </p14:section>
-        <p14:section name="Ruta y alcance" id="{e0480680-65d1-88c4-cbad-6805888f2697}">
+        <p14:section name="Ruta y alcance" id="{d531f546-bf48-0761-9c8d-575559fe48bf}">
           <p14:sldIdLst>
             <p14:sldId id="264"/>
             <p14:sldId id="265"/>

</xml_diff>

<commit_message>
Nueva foto de Carolina y corrige la conclusión de Lina
Co-Authored-By: Claude Opus 5.5 <noreply@anthropic.com>
Claude-Session: https://claude.ai/code/session_018mufWPZrGGp9c32gWXHPYT
</commit_message>
<xml_diff>
--- a/files/Accountability_TALENT.pptx
+++ b/files/Accountability_TALENT.pptx
@@ -118,19 +118,19 @@
   <p:extLst>
     <p:ext uri="{521415D9-36F7-43E2-AB2F-B90AF26B5E84}">
       <p14:sectionLst xmlns:p14="http://schemas.microsoft.com/office/powerpoint/2010/main">
-        <p14:section name="Equipo y unidad de análisis" id="{11f0a217-c063-aa25-f0dc-fe1dc68fc88d}">
+        <p14:section name="Equipo y unidad de análisis" id="{f3c4011c-eebe-ad28-68e7-2eac83977aee}">
           <p14:sldIdLst>
             <p14:sldId id="256"/>
             <p14:sldId id="257"/>
             <p14:sldId id="258"/>
           </p14:sldIdLst>
         </p14:section>
-        <p14:section name="Modelo de negocio" id="{9a7c011b-9842-55b8-b787-fe24b91fee32}">
+        <p14:section name="Modelo de negocio" id="{4696fe98-71c3-d845-fb7a-a4863c7014c2}">
           <p14:sldIdLst>
             <p14:sldId id="259"/>
           </p14:sldIdLst>
         </p14:section>
-        <p14:section name="Diagnóstico" id="{8bf727aa-2af1-93ab-b015-cbebfc5de34c}">
+        <p14:section name="Diagnóstico" id="{6a03721b-1064-b72d-114b-d515ebfc77e2}">
           <p14:sldIdLst>
             <p14:sldId id="260"/>
             <p14:sldId id="261"/>
@@ -138,7 +138,7 @@
             <p14:sldId id="263"/>
           </p14:sldIdLst>
         </p14:section>
-        <p14:section name="Ruta y alcance" id="{d531f546-bf48-0761-9c8d-575559fe48bf}">
+        <p14:section name="Ruta y alcance" id="{e04ed04a-f54c-4bab-b747-cdea98cb275f}">
           <p14:sldIdLst>
             <p14:sldId id="264"/>
             <p14:sldId id="265"/>

</xml_diff>

<commit_message>
Corrige datos del test, TA4 en semanas 7 y 8, lentes y consentimiento informado
Co-Authored-By: Claude Opus 5.5 <noreply@anthropic.com>
Claude-Session: https://claude.ai/code/session_018mufWPZrGGp9c32gWXHPYT
</commit_message>
<xml_diff>
--- a/files/Accountability_TALENT.pptx
+++ b/files/Accountability_TALENT.pptx
@@ -17,9 +17,10 @@
     <p:sldId id="265" r:id="rId11"/>
     <p:sldId id="266" r:id="rId12"/>
     <p:sldId id="267" r:id="rId13"/>
+    <p:sldId id="268" r:id="rId14"/>
   </p:sldIdLst>
   <p:notesMasterIdLst>
-    <p:notesMasterId r:id="rId14"/>
+    <p:notesMasterId r:id="rId15"/>
   </p:notesMasterIdLst>
   <p:sldSz cx="12192000" cy="6858000"/>
   <p:notesSz cx="6858000" cy="12192000"/>
@@ -118,19 +119,19 @@
   <p:extLst>
     <p:ext uri="{521415D9-36F7-43E2-AB2F-B90AF26B5E84}">
       <p14:sectionLst xmlns:p14="http://schemas.microsoft.com/office/powerpoint/2010/main">
-        <p14:section name="Equipo y unidad de análisis" id="{f3c4011c-eebe-ad28-68e7-2eac83977aee}">
+        <p14:section name="Equipo y unidad de análisis" id="{76418694-afcb-e236-adc2-96566602cfd8}">
           <p14:sldIdLst>
             <p14:sldId id="256"/>
             <p14:sldId id="257"/>
             <p14:sldId id="258"/>
           </p14:sldIdLst>
         </p14:section>
-        <p14:section name="Modelo de negocio" id="{4696fe98-71c3-d845-fb7a-a4863c7014c2}">
+        <p14:section name="Modelo de negocio" id="{5f54341f-8645-4461-bcf6-43e29ad494f5}">
           <p14:sldIdLst>
             <p14:sldId id="259"/>
           </p14:sldIdLst>
         </p14:section>
-        <p14:section name="Diagnóstico" id="{6a03721b-1064-b72d-114b-d515ebfc77e2}">
+        <p14:section name="Diagnóstico" id="{39936f4b-0c25-3578-2168-e62d8ff34bd8}">
           <p14:sldIdLst>
             <p14:sldId id="260"/>
             <p14:sldId id="261"/>
@@ -138,12 +139,13 @@
             <p14:sldId id="263"/>
           </p14:sldIdLst>
         </p14:section>
-        <p14:section name="Ruta y alcance" id="{e04ed04a-f54c-4bab-b747-cdea98cb275f}">
+        <p14:section name="Ruta y alcance" id="{65493156-ece9-0086-52cd-bd885c56819b}">
           <p14:sldIdLst>
             <p14:sldId id="264"/>
             <p14:sldId id="265"/>
             <p14:sldId id="266"/>
             <p14:sldId id="267"/>
+            <p14:sldId id="268"/>
           </p14:sldIdLst>
         </p14:section>
       </p14:sectionLst>
@@ -726,7 +728,7 @@
           <a:p>
             <a:r>
               <a:rPr lang="en-US" dirty="0"/>
-              <a:t>Cerrar con compromisos concretos del cliente y la fecha de la próxima sesión.</a:t>
+              <a:t>Lente ética del módulo: explicar al cliente qué hacemos con su información, quién la ve y qué pasa si el diagnóstico es desfavorable.</a:t>
             </a:r>
             <a:endParaRPr lang="en-US" dirty="0"/>
           </a:p>
@@ -814,7 +816,7 @@
           <a:p>
             <a:r>
               <a:rPr lang="en-US" dirty="0"/>
-              <a:t>Agradecer, abrir espacio para preguntas del cliente y confirmar la próxima sesión.</a:t>
+              <a:t>Cerrar con compromisos concretos del cliente y la fecha de la próxima sesión.</a:t>
             </a:r>
             <a:endParaRPr lang="en-US" dirty="0"/>
           </a:p>
@@ -838,6 +840,94 @@
             <a:fld id="{F7021451-1387-4CA6-816F-3879F97B5CBC}" type="slidenum">
               <a:rPr lang="en-US"/>
               <a:t>12</a:t>
+            </a:fld>
+            <a:endParaRPr lang="en-US"/>
+          </a:p>
+        </p:txBody>
+      </p:sp>
+    </p:spTree>
+    <p:extLst>
+      <p:ext uri="{BB962C8B-B14F-4D97-AF65-F5344CB8AC3E}">
+        <p14:creationId xmlns:p14="http://schemas.microsoft.com/office/powerpoint/2010/main" val="1024086991"/>
+      </p:ext>
+    </p:extLst>
+  </p:cSld>
+  <p:clrMapOvr>
+    <a:masterClrMapping/>
+  </p:clrMapOvr>
+</p:notes>
+</file>
+
+<file path=ppt/notesSlides/notesSlide13.xml><?xml version="1.0" encoding="utf-8"?>
+<p:notes xmlns:a="http://schemas.openxmlformats.org/drawingml/2006/main" xmlns:r="http://schemas.openxmlformats.org/officeDocument/2006/relationships" xmlns:p="http://schemas.openxmlformats.org/presentationml/2006/main">
+  <p:cSld>
+    <p:spTree>
+      <p:nvGrpSpPr>
+        <p:cNvPr id="1" name=""/>
+        <p:cNvGrpSpPr/>
+        <p:nvPr/>
+      </p:nvGrpSpPr>
+      <p:grpSpPr>
+        <a:xfrm>
+          <a:off x="0" y="0"/>
+          <a:ext cx="0" cy="0"/>
+          <a:chOff x="0" y="0"/>
+          <a:chExt cx="0" cy="0"/>
+        </a:xfrm>
+      </p:grpSpPr>
+      <p:sp>
+        <p:nvSpPr>
+          <p:cNvPr id="2" name="Slide Image Placeholder 1"/>
+          <p:cNvSpPr>
+            <a:spLocks noGrp="1" noRot="1" noChangeAspect="1"/>
+          </p:cNvSpPr>
+          <p:nvPr>
+            <p:ph type="sldImg"/>
+          </p:nvPr>
+        </p:nvSpPr>
+        <p:spPr/>
+      </p:sp>
+      <p:sp>
+        <p:nvSpPr>
+          <p:cNvPr id="3" name="Notes Placeholder 2"/>
+          <p:cNvSpPr>
+            <a:spLocks noGrp="1"/>
+          </p:cNvSpPr>
+          <p:nvPr>
+            <p:ph type="body" idx="1"/>
+          </p:nvPr>
+        </p:nvSpPr>
+        <p:spPr/>
+        <p:txBody>
+          <a:bodyPr/>
+          <a:lstStyle/>
+          <a:p>
+            <a:r>
+              <a:rPr lang="en-US" dirty="0"/>
+              <a:t>Agradecer, abrir espacio para preguntas del cliente y confirmar la próxima sesión.</a:t>
+            </a:r>
+            <a:endParaRPr lang="en-US" dirty="0"/>
+          </a:p>
+        </p:txBody>
+      </p:sp>
+      <p:sp>
+        <p:nvSpPr>
+          <p:cNvPr id="4" name="Slide Number Placeholder 3"/>
+          <p:cNvSpPr>
+            <a:spLocks noGrp="1"/>
+          </p:cNvSpPr>
+          <p:nvPr>
+            <p:ph type="sldNum" sz="quarter" idx="10"/>
+          </p:nvPr>
+        </p:nvSpPr>
+        <p:spPr/>
+        <p:txBody>
+          <a:bodyPr/>
+          <a:lstStyle/>
+          <a:p>
+            <a:fld id="{F7021451-1387-4CA6-816F-3879F97B5CBC}" type="slidenum">
+              <a:rPr lang="en-US"/>
+              <a:t>13</a:t>
             </a:fld>
             <a:endParaRPr lang="en-US"/>
           </a:p>
@@ -3141,7 +3231,7 @@
                 <a:ea typeface="Courier New" pitchFamily="34" charset="-122"/>
                 <a:cs typeface="Courier New" pitchFamily="34" charset="-120"/>
               </a:rPr>
-              <a:t>10 · PRÓXIMOS PASOS</a:t>
+              <a:t>10 · TU INFORMACIÓN</a:t>
             </a:r>
             <a:endParaRPr lang="en-US" sz="1300" dirty="0"/>
           </a:p>
@@ -3180,7 +3270,7 @@
                 <a:ea typeface="Calibri" pitchFamily="34" charset="-122"/>
                 <a:cs typeface="Calibri" pitchFamily="34" charset="-120"/>
               </a:rPr>
-              <a:t>Lo que necesitamos de TALENT</a:t>
+              <a:t>Cómo cuidamos la información de TALENT</a:t>
             </a:r>
             <a:endParaRPr lang="en-US" sz="4000" dirty="0"/>
           </a:p>
@@ -3188,14 +3278,144 @@
       </p:sp>
       <p:sp>
         <p:nvSpPr>
-          <p:cNvPr id="4" name="Text 2"/>
-          <p:cNvSpPr txBox="1"/>
+          <p:cNvPr id="4" name="Shape 2"/>
+          <p:cNvSpPr/>
           <p:nvPr/>
         </p:nvSpPr>
         <p:spPr>
           <a:xfrm>
             <a:off x="548640" y="1920240"/>
-            <a:ext cx="4846320" cy="1463040"/>
+            <a:ext cx="3566160" cy="3291840"/>
+          </a:xfrm>
+          <a:prstGeom prst="roundRect">
+            <a:avLst>
+              <a:gd name="adj" fmla="val 4167"/>
+            </a:avLst>
+          </a:prstGeom>
+          <a:solidFill>
+            <a:srgbClr val="1A1816"/>
+          </a:solidFill>
+          <a:ln w="12700">
+            <a:solidFill>
+              <a:srgbClr val="1A1816"/>
+            </a:solidFill>
+            <a:prstDash val="solid"/>
+          </a:ln>
+        </p:spPr>
+      </p:sp>
+      <p:sp>
+        <p:nvSpPr>
+          <p:cNvPr id="5" name="Shape 3"/>
+          <p:cNvSpPr/>
+          <p:nvPr/>
+        </p:nvSpPr>
+        <p:spPr>
+          <a:xfrm>
+            <a:off x="868680" y="2194560"/>
+            <a:ext cx="502920" cy="502920"/>
+          </a:xfrm>
+          <a:prstGeom prst="ellipse">
+            <a:avLst/>
+          </a:prstGeom>
+          <a:solidFill>
+            <a:srgbClr val="E5D9C3"/>
+          </a:solidFill>
+          <a:ln w="12700">
+            <a:solidFill>
+              <a:srgbClr val="E5D9C3"/>
+            </a:solidFill>
+            <a:prstDash val="solid"/>
+          </a:ln>
+        </p:spPr>
+      </p:sp>
+      <p:sp>
+        <p:nvSpPr>
+          <p:cNvPr id="6" name="Text 4"/>
+          <p:cNvSpPr txBox="1"/>
+          <p:nvPr/>
+        </p:nvSpPr>
+        <p:spPr>
+          <a:xfrm>
+            <a:off x="868680" y="2194560"/>
+            <a:ext cx="502920" cy="502920"/>
+          </a:xfrm>
+          <a:prstGeom prst="rect">
+            <a:avLst/>
+          </a:prstGeom>
+          <a:noFill/>
+          <a:ln/>
+        </p:spPr>
+        <p:txBody>
+          <a:bodyPr wrap="square" lIns="0" tIns="0" rIns="0" bIns="0" rtlCol="0" anchor="ctr"/>
+          <a:lstStyle/>
+          <a:p>
+            <a:pPr algn="ctr" indent="0" marL="0">
+              <a:buNone/>
+            </a:pPr>
+            <a:r>
+              <a:rPr lang="en-US" sz="1800" b="1" dirty="0">
+                <a:solidFill>
+                  <a:srgbClr val="0F0F0F"/>
+                </a:solidFill>
+                <a:latin typeface="Calibri" pitchFamily="34" charset="0"/>
+                <a:ea typeface="Calibri" pitchFamily="34" charset="-122"/>
+                <a:cs typeface="Calibri" pitchFamily="34" charset="-120"/>
+              </a:rPr>
+              <a:t>1</a:t>
+            </a:r>
+            <a:endParaRPr lang="en-US" sz="1800" dirty="0"/>
+          </a:p>
+        </p:txBody>
+      </p:sp>
+      <p:sp>
+        <p:nvSpPr>
+          <p:cNvPr id="7" name="Text 5"/>
+          <p:cNvSpPr txBox="1"/>
+          <p:nvPr/>
+        </p:nvSpPr>
+        <p:spPr>
+          <a:xfrm>
+            <a:off x="868680" y="2926080"/>
+            <a:ext cx="2926080" cy="731520"/>
+          </a:xfrm>
+          <a:prstGeom prst="rect">
+            <a:avLst/>
+          </a:prstGeom>
+          <a:noFill/>
+          <a:ln/>
+        </p:spPr>
+        <p:txBody>
+          <a:bodyPr wrap="square" lIns="0" tIns="0" rIns="0" bIns="0" rtlCol="0" anchor="t"/>
+          <a:lstStyle/>
+          <a:p>
+            <a:pPr indent="0" marL="0">
+              <a:buNone/>
+            </a:pPr>
+            <a:r>
+              <a:rPr lang="en-US" sz="2000" b="1" dirty="0">
+                <a:solidFill>
+                  <a:srgbClr val="F3EFE7"/>
+                </a:solidFill>
+                <a:latin typeface="Calibri" pitchFamily="34" charset="0"/>
+                <a:ea typeface="Calibri" pitchFamily="34" charset="-122"/>
+                <a:cs typeface="Calibri" pitchFamily="34" charset="-120"/>
+              </a:rPr>
+              <a:t>¿Qué hacemos con ella?</a:t>
+            </a:r>
+            <a:endParaRPr lang="en-US" sz="2000" dirty="0"/>
+          </a:p>
+        </p:txBody>
+      </p:sp>
+      <p:sp>
+        <p:nvSpPr>
+          <p:cNvPr id="8" name="Text 6"/>
+          <p:cNvSpPr txBox="1"/>
+          <p:nvPr/>
+        </p:nvSpPr>
+        <p:spPr>
+          <a:xfrm>
+            <a:off x="868680" y="3703320"/>
+            <a:ext cx="2926080" cy="1371600"/>
           </a:xfrm>
           <a:prstGeom prst="rect">
             <a:avLst/>
@@ -3214,155 +3434,214 @@
               <a:buNone/>
             </a:pPr>
             <a:r>
-              <a:rPr lang="en-US" sz="2000" dirty="0">
-                <a:solidFill>
-                  <a:srgbClr val="D9D3C8"/>
+              <a:rPr lang="en-US" sz="1500" dirty="0">
+                <a:solidFill>
+                  <a:srgbClr val="A39C90"/>
                 </a:solidFill>
                 <a:latin typeface="Calibri" pitchFamily="34" charset="0"/>
                 <a:ea typeface="Calibri" pitchFamily="34" charset="-122"/>
                 <a:cs typeface="Calibri" pitchFamily="34" charset="-120"/>
               </a:rPr>
-              <a:t>Para empezar TA1 el 2 de noviembre, pedimos a la fundadora estos soportes y su aceptación del alcance.</a:t>
-            </a:r>
-            <a:endParaRPr lang="en-US" sz="2000" dirty="0"/>
-          </a:p>
-        </p:txBody>
-      </p:sp>
-      <p:sp>
-        <p:nvSpPr>
-          <p:cNvPr id="5" name="Text 3"/>
-          <p:cNvSpPr txBox="1"/>
-          <p:nvPr/>
-        </p:nvSpPr>
-        <p:spPr>
-          <a:xfrm>
-            <a:off x="6309360" y="1920240"/>
-            <a:ext cx="548640" cy="365760"/>
-          </a:xfrm>
-          <a:prstGeom prst="rect">
-            <a:avLst/>
-          </a:prstGeom>
-          <a:noFill/>
-          <a:ln/>
-        </p:spPr>
-        <p:txBody>
-          <a:bodyPr wrap="square" lIns="0" tIns="0" rIns="0" bIns="0" rtlCol="0" anchor="t"/>
-          <a:lstStyle/>
-          <a:p>
-            <a:pPr indent="0" marL="0">
-              <a:buNone/>
-            </a:pPr>
-            <a:r>
-              <a:rPr lang="en-US" sz="1400" dirty="0">
-                <a:solidFill>
-                  <a:srgbClr val="E5D9C3"/>
-                </a:solidFill>
-                <a:latin typeface="Courier New" pitchFamily="34" charset="0"/>
-                <a:ea typeface="Courier New" pitchFamily="34" charset="-122"/>
-                <a:cs typeface="Courier New" pitchFamily="34" charset="-120"/>
-              </a:rPr>
-              <a:t>01</a:t>
-            </a:r>
-            <a:endParaRPr lang="en-US" sz="1400" dirty="0"/>
-          </a:p>
-        </p:txBody>
-      </p:sp>
-      <p:sp>
-        <p:nvSpPr>
-          <p:cNvPr id="6" name="Text 4"/>
-          <p:cNvSpPr txBox="1"/>
-          <p:nvPr/>
-        </p:nvSpPr>
-        <p:spPr>
-          <a:xfrm>
-            <a:off x="6949440" y="1920240"/>
-            <a:ext cx="4663440" cy="365760"/>
-          </a:xfrm>
-          <a:prstGeom prst="rect">
-            <a:avLst/>
-          </a:prstGeom>
-          <a:noFill/>
-          <a:ln/>
-        </p:spPr>
-        <p:txBody>
-          <a:bodyPr wrap="square" lIns="0" tIns="0" rIns="0" bIns="0" rtlCol="0" anchor="t"/>
-          <a:lstStyle/>
-          <a:p>
-            <a:pPr indent="0" marL="0">
-              <a:buNone/>
-            </a:pPr>
-            <a:r>
-              <a:rPr lang="en-US" sz="1900" b="1" dirty="0">
-                <a:solidFill>
-                  <a:srgbClr val="F3EFE7"/>
+              <a:t>La usamos solo para el diagnóstico y los entregables del curso. No la compartimos con terceros.</a:t>
+            </a:r>
+            <a:endParaRPr lang="en-US" sz="1500" dirty="0"/>
+          </a:p>
+        </p:txBody>
+      </p:sp>
+      <p:sp>
+        <p:nvSpPr>
+          <p:cNvPr id="9" name="Shape 7"/>
+          <p:cNvSpPr/>
+          <p:nvPr/>
+        </p:nvSpPr>
+        <p:spPr>
+          <a:xfrm>
+            <a:off x="4325112" y="1920240"/>
+            <a:ext cx="3566160" cy="3291840"/>
+          </a:xfrm>
+          <a:prstGeom prst="roundRect">
+            <a:avLst>
+              <a:gd name="adj" fmla="val 4167"/>
+            </a:avLst>
+          </a:prstGeom>
+          <a:solidFill>
+            <a:srgbClr val="1A1816"/>
+          </a:solidFill>
+          <a:ln w="12700">
+            <a:solidFill>
+              <a:srgbClr val="1A1816"/>
+            </a:solidFill>
+            <a:prstDash val="solid"/>
+          </a:ln>
+        </p:spPr>
+      </p:sp>
+      <p:sp>
+        <p:nvSpPr>
+          <p:cNvPr id="10" name="Shape 8"/>
+          <p:cNvSpPr/>
+          <p:nvPr/>
+        </p:nvSpPr>
+        <p:spPr>
+          <a:xfrm>
+            <a:off x="4645152" y="2194560"/>
+            <a:ext cx="502920" cy="502920"/>
+          </a:xfrm>
+          <a:prstGeom prst="ellipse">
+            <a:avLst/>
+          </a:prstGeom>
+          <a:solidFill>
+            <a:srgbClr val="E5D9C3"/>
+          </a:solidFill>
+          <a:ln w="12700">
+            <a:solidFill>
+              <a:srgbClr val="E5D9C3"/>
+            </a:solidFill>
+            <a:prstDash val="solid"/>
+          </a:ln>
+        </p:spPr>
+      </p:sp>
+      <p:sp>
+        <p:nvSpPr>
+          <p:cNvPr id="11" name="Text 9"/>
+          <p:cNvSpPr txBox="1"/>
+          <p:nvPr/>
+        </p:nvSpPr>
+        <p:spPr>
+          <a:xfrm>
+            <a:off x="4645152" y="2194560"/>
+            <a:ext cx="502920" cy="502920"/>
+          </a:xfrm>
+          <a:prstGeom prst="rect">
+            <a:avLst/>
+          </a:prstGeom>
+          <a:noFill/>
+          <a:ln/>
+        </p:spPr>
+        <p:txBody>
+          <a:bodyPr wrap="square" lIns="0" tIns="0" rIns="0" bIns="0" rtlCol="0" anchor="ctr"/>
+          <a:lstStyle/>
+          <a:p>
+            <a:pPr algn="ctr" indent="0" marL="0">
+              <a:buNone/>
+            </a:pPr>
+            <a:r>
+              <a:rPr lang="en-US" sz="1800" b="1" dirty="0">
+                <a:solidFill>
+                  <a:srgbClr val="0F0F0F"/>
                 </a:solidFill>
                 <a:latin typeface="Calibri" pitchFamily="34" charset="0"/>
                 <a:ea typeface="Calibri" pitchFamily="34" charset="-122"/>
                 <a:cs typeface="Calibri" pitchFamily="34" charset="-120"/>
               </a:rPr>
-              <a:t>Firmar el acta del diagnóstico</a:t>
-            </a:r>
-            <a:endParaRPr lang="en-US" sz="1900" dirty="0"/>
-          </a:p>
-        </p:txBody>
-      </p:sp>
-      <p:sp>
-        <p:nvSpPr>
-          <p:cNvPr id="7" name="Text 5"/>
-          <p:cNvSpPr txBox="1"/>
-          <p:nvPr/>
-        </p:nvSpPr>
-        <p:spPr>
-          <a:xfrm>
-            <a:off x="6949440" y="2331720"/>
-            <a:ext cx="4663440" cy="320040"/>
-          </a:xfrm>
-          <a:prstGeom prst="rect">
-            <a:avLst/>
-          </a:prstGeom>
-          <a:noFill/>
-          <a:ln/>
-        </p:spPr>
-        <p:txBody>
-          <a:bodyPr wrap="square" lIns="0" tIns="0" rIns="0" bIns="0" rtlCol="0" anchor="t"/>
-          <a:lstStyle/>
-          <a:p>
-            <a:pPr indent="0" marL="0">
-              <a:buNone/>
-            </a:pPr>
-            <a:r>
-              <a:rPr lang="en-US" sz="1400" dirty="0">
-                <a:solidFill>
-                  <a:srgbClr val="A39C90"/>
+              <a:t>2</a:t>
+            </a:r>
+            <a:endParaRPr lang="en-US" sz="1800" dirty="0"/>
+          </a:p>
+        </p:txBody>
+      </p:sp>
+      <p:sp>
+        <p:nvSpPr>
+          <p:cNvPr id="12" name="Text 10"/>
+          <p:cNvSpPr txBox="1"/>
+          <p:nvPr/>
+        </p:nvSpPr>
+        <p:spPr>
+          <a:xfrm>
+            <a:off x="4645152" y="2926080"/>
+            <a:ext cx="2926080" cy="731520"/>
+          </a:xfrm>
+          <a:prstGeom prst="rect">
+            <a:avLst/>
+          </a:prstGeom>
+          <a:noFill/>
+          <a:ln/>
+        </p:spPr>
+        <p:txBody>
+          <a:bodyPr wrap="square" lIns="0" tIns="0" rIns="0" bIns="0" rtlCol="0" anchor="t"/>
+          <a:lstStyle/>
+          <a:p>
+            <a:pPr indent="0" marL="0">
+              <a:buNone/>
+            </a:pPr>
+            <a:r>
+              <a:rPr lang="en-US" sz="2000" b="1" dirty="0">
+                <a:solidFill>
+                  <a:srgbClr val="F3EFE7"/>
                 </a:solidFill>
                 <a:latin typeface="Calibri" pitchFamily="34" charset="0"/>
                 <a:ea typeface="Calibri" pitchFamily="34" charset="-122"/>
                 <a:cs typeface="Calibri" pitchFamily="34" charset="-120"/>
               </a:rPr>
-              <a:t>Confirma las respuestas del 27 de octubre</a:t>
-            </a:r>
-            <a:endParaRPr lang="en-US" sz="1400" dirty="0"/>
-          </a:p>
-        </p:txBody>
-      </p:sp>
-      <p:sp>
-        <p:nvSpPr>
-          <p:cNvPr id="8" name="Shape 6"/>
+              <a:t>¿Quién la ve?</a:t>
+            </a:r>
+            <a:endParaRPr lang="en-US" sz="2000" dirty="0"/>
+          </a:p>
+        </p:txBody>
+      </p:sp>
+      <p:sp>
+        <p:nvSpPr>
+          <p:cNvPr id="13" name="Text 11"/>
+          <p:cNvSpPr txBox="1"/>
+          <p:nvPr/>
+        </p:nvSpPr>
+        <p:spPr>
+          <a:xfrm>
+            <a:off x="4645152" y="3703320"/>
+            <a:ext cx="2926080" cy="1371600"/>
+          </a:xfrm>
+          <a:prstGeom prst="rect">
+            <a:avLst/>
+          </a:prstGeom>
+          <a:noFill/>
+          <a:ln/>
+        </p:spPr>
+        <p:txBody>
+          <a:bodyPr wrap="square" lIns="0" tIns="0" rIns="0" bIns="0" rtlCol="0" anchor="t"/>
+          <a:lstStyle/>
+          <a:p>
+            <a:pPr indent="0" marL="0">
+              <a:lnSpc>
+                <a:spcPct val="120000"/>
+              </a:lnSpc>
+              <a:buNone/>
+            </a:pPr>
+            <a:r>
+              <a:rPr lang="en-US" sz="1500" dirty="0">
+                <a:solidFill>
+                  <a:srgbClr val="A39C90"/>
+                </a:solidFill>
+                <a:latin typeface="Calibri" pitchFamily="34" charset="0"/>
+                <a:ea typeface="Calibri" pitchFamily="34" charset="-122"/>
+                <a:cs typeface="Calibri" pitchFamily="34" charset="-120"/>
+              </a:rPr>
+              <a:t>El equipo consultor y el docente. Los documentos personales (RUT, PILA, cédula) no se publican en el Data Room.</a:t>
+            </a:r>
+            <a:endParaRPr lang="en-US" sz="1500" dirty="0"/>
+          </a:p>
+        </p:txBody>
+      </p:sp>
+      <p:sp>
+        <p:nvSpPr>
+          <p:cNvPr id="14" name="Shape 12"/>
           <p:cNvSpPr/>
           <p:nvPr/>
         </p:nvSpPr>
         <p:spPr>
           <a:xfrm>
-            <a:off x="6309360" y="2788920"/>
-            <a:ext cx="5349240" cy="0"/>
-          </a:xfrm>
-          <a:prstGeom prst="line">
-            <a:avLst/>
-          </a:prstGeom>
-          <a:noFill/>
-          <a:ln w="9525">
+            <a:off x="8101584" y="1920240"/>
+            <a:ext cx="3566160" cy="3291840"/>
+          </a:xfrm>
+          <a:prstGeom prst="roundRect">
+            <a:avLst>
+              <a:gd name="adj" fmla="val 4167"/>
+            </a:avLst>
+          </a:prstGeom>
+          <a:solidFill>
+            <a:srgbClr val="1A1816"/>
+          </a:solidFill>
+          <a:ln w="12700">
             <a:solidFill>
-              <a:srgbClr val="2E2B27"/>
+              <a:srgbClr val="1A1816"/>
             </a:solidFill>
             <a:prstDash val="solid"/>
           </a:ln>
@@ -3370,398 +3649,199 @@
       </p:sp>
       <p:sp>
         <p:nvSpPr>
-          <p:cNvPr id="9" name="Text 7"/>
-          <p:cNvSpPr txBox="1"/>
-          <p:nvPr/>
-        </p:nvSpPr>
-        <p:spPr>
-          <a:xfrm>
-            <a:off x="6309360" y="2907792"/>
-            <a:ext cx="548640" cy="365760"/>
-          </a:xfrm>
-          <a:prstGeom prst="rect">
-            <a:avLst/>
-          </a:prstGeom>
-          <a:noFill/>
-          <a:ln/>
-        </p:spPr>
-        <p:txBody>
-          <a:bodyPr wrap="square" lIns="0" tIns="0" rIns="0" bIns="0" rtlCol="0" anchor="t"/>
-          <a:lstStyle/>
-          <a:p>
-            <a:pPr indent="0" marL="0">
-              <a:buNone/>
-            </a:pPr>
-            <a:r>
-              <a:rPr lang="en-US" sz="1400" dirty="0">
-                <a:solidFill>
-                  <a:srgbClr val="E5D9C3"/>
-                </a:solidFill>
-                <a:latin typeface="Courier New" pitchFamily="34" charset="0"/>
-                <a:ea typeface="Courier New" pitchFamily="34" charset="-122"/>
-                <a:cs typeface="Courier New" pitchFamily="34" charset="-120"/>
-              </a:rPr>
-              <a:t>02</a:t>
-            </a:r>
-            <a:endParaRPr lang="en-US" sz="1400" dirty="0"/>
-          </a:p>
-        </p:txBody>
-      </p:sp>
-      <p:sp>
-        <p:nvSpPr>
-          <p:cNvPr id="10" name="Text 8"/>
-          <p:cNvSpPr txBox="1"/>
-          <p:nvPr/>
-        </p:nvSpPr>
-        <p:spPr>
-          <a:xfrm>
-            <a:off x="6949440" y="2907792"/>
-            <a:ext cx="4663440" cy="365760"/>
-          </a:xfrm>
-          <a:prstGeom prst="rect">
-            <a:avLst/>
-          </a:prstGeom>
-          <a:noFill/>
-          <a:ln/>
-        </p:spPr>
-        <p:txBody>
-          <a:bodyPr wrap="square" lIns="0" tIns="0" rIns="0" bIns="0" rtlCol="0" anchor="t"/>
-          <a:lstStyle/>
-          <a:p>
-            <a:pPr indent="0" marL="0">
-              <a:buNone/>
-            </a:pPr>
-            <a:r>
-              <a:rPr lang="en-US" sz="1900" b="1" dirty="0">
-                <a:solidFill>
-                  <a:srgbClr val="F3EFE7"/>
+          <p:cNvPr id="15" name="Shape 13"/>
+          <p:cNvSpPr/>
+          <p:nvPr/>
+        </p:nvSpPr>
+        <p:spPr>
+          <a:xfrm>
+            <a:off x="8421624" y="2194560"/>
+            <a:ext cx="502920" cy="502920"/>
+          </a:xfrm>
+          <a:prstGeom prst="ellipse">
+            <a:avLst/>
+          </a:prstGeom>
+          <a:solidFill>
+            <a:srgbClr val="E5D9C3"/>
+          </a:solidFill>
+          <a:ln w="12700">
+            <a:solidFill>
+              <a:srgbClr val="E5D9C3"/>
+            </a:solidFill>
+            <a:prstDash val="solid"/>
+          </a:ln>
+        </p:spPr>
+      </p:sp>
+      <p:sp>
+        <p:nvSpPr>
+          <p:cNvPr id="16" name="Text 14"/>
+          <p:cNvSpPr txBox="1"/>
+          <p:nvPr/>
+        </p:nvSpPr>
+        <p:spPr>
+          <a:xfrm>
+            <a:off x="8421624" y="2194560"/>
+            <a:ext cx="502920" cy="502920"/>
+          </a:xfrm>
+          <a:prstGeom prst="rect">
+            <a:avLst/>
+          </a:prstGeom>
+          <a:noFill/>
+          <a:ln/>
+        </p:spPr>
+        <p:txBody>
+          <a:bodyPr wrap="square" lIns="0" tIns="0" rIns="0" bIns="0" rtlCol="0" anchor="ctr"/>
+          <a:lstStyle/>
+          <a:p>
+            <a:pPr algn="ctr" indent="0" marL="0">
+              <a:buNone/>
+            </a:pPr>
+            <a:r>
+              <a:rPr lang="en-US" sz="1800" b="1" dirty="0">
+                <a:solidFill>
+                  <a:srgbClr val="0F0F0F"/>
                 </a:solidFill>
                 <a:latin typeface="Calibri" pitchFamily="34" charset="0"/>
                 <a:ea typeface="Calibri" pitchFamily="34" charset="-122"/>
                 <a:cs typeface="Calibri" pitchFamily="34" charset="-120"/>
               </a:rPr>
-              <a:t>Compartir los soportes</a:t>
-            </a:r>
-            <a:endParaRPr lang="en-US" sz="1900" dirty="0"/>
-          </a:p>
-        </p:txBody>
-      </p:sp>
-      <p:sp>
-        <p:nvSpPr>
-          <p:cNvPr id="11" name="Text 9"/>
-          <p:cNvSpPr txBox="1"/>
-          <p:nvPr/>
-        </p:nvSpPr>
-        <p:spPr>
-          <a:xfrm>
-            <a:off x="6949440" y="3319272"/>
-            <a:ext cx="4663440" cy="320040"/>
-          </a:xfrm>
-          <a:prstGeom prst="rect">
-            <a:avLst/>
-          </a:prstGeom>
-          <a:noFill/>
-          <a:ln/>
-        </p:spPr>
-        <p:txBody>
-          <a:bodyPr wrap="square" lIns="0" tIns="0" rIns="0" bIns="0" rtlCol="0" anchor="t"/>
-          <a:lstStyle/>
-          <a:p>
-            <a:pPr indent="0" marL="0">
-              <a:buNone/>
-            </a:pPr>
-            <a:r>
-              <a:rPr lang="en-US" sz="1400" dirty="0">
-                <a:solidFill>
-                  <a:srgbClr val="A39C90"/>
+              <a:t>3</a:t>
+            </a:r>
+            <a:endParaRPr lang="en-US" sz="1800" dirty="0"/>
+          </a:p>
+        </p:txBody>
+      </p:sp>
+      <p:sp>
+        <p:nvSpPr>
+          <p:cNvPr id="17" name="Text 15"/>
+          <p:cNvSpPr txBox="1"/>
+          <p:nvPr/>
+        </p:nvSpPr>
+        <p:spPr>
+          <a:xfrm>
+            <a:off x="8421624" y="2926080"/>
+            <a:ext cx="2926080" cy="731520"/>
+          </a:xfrm>
+          <a:prstGeom prst="rect">
+            <a:avLst/>
+          </a:prstGeom>
+          <a:noFill/>
+          <a:ln/>
+        </p:spPr>
+        <p:txBody>
+          <a:bodyPr wrap="square" lIns="0" tIns="0" rIns="0" bIns="0" rtlCol="0" anchor="t"/>
+          <a:lstStyle/>
+          <a:p>
+            <a:pPr indent="0" marL="0">
+              <a:buNone/>
+            </a:pPr>
+            <a:r>
+              <a:rPr lang="en-US" sz="2000" b="1" dirty="0">
+                <a:solidFill>
+                  <a:srgbClr val="F3EFE7"/>
                 </a:solidFill>
                 <a:latin typeface="Calibri" pitchFamily="34" charset="0"/>
                 <a:ea typeface="Calibri" pitchFamily="34" charset="-122"/>
                 <a:cs typeface="Calibri" pitchFamily="34" charset="-120"/>
               </a:rPr>
-              <a:t>RUT, planilla PILA y licencia SST de la aliada</a:t>
-            </a:r>
-            <a:endParaRPr lang="en-US" sz="1400" dirty="0"/>
-          </a:p>
-        </p:txBody>
-      </p:sp>
-      <p:sp>
-        <p:nvSpPr>
-          <p:cNvPr id="12" name="Shape 10"/>
-          <p:cNvSpPr/>
-          <p:nvPr/>
-        </p:nvSpPr>
-        <p:spPr>
-          <a:xfrm>
-            <a:off x="6309360" y="3776472"/>
-            <a:ext cx="5349240" cy="0"/>
-          </a:xfrm>
-          <a:prstGeom prst="line">
-            <a:avLst/>
-          </a:prstGeom>
-          <a:noFill/>
-          <a:ln w="9525">
-            <a:solidFill>
-              <a:srgbClr val="2E2B27"/>
-            </a:solidFill>
-            <a:prstDash val="solid"/>
-          </a:ln>
-        </p:spPr>
-      </p:sp>
-      <p:sp>
-        <p:nvSpPr>
-          <p:cNvPr id="13" name="Text 11"/>
-          <p:cNvSpPr txBox="1"/>
-          <p:nvPr/>
-        </p:nvSpPr>
-        <p:spPr>
-          <a:xfrm>
-            <a:off x="6309360" y="3895344"/>
-            <a:ext cx="548640" cy="365760"/>
-          </a:xfrm>
-          <a:prstGeom prst="rect">
-            <a:avLst/>
-          </a:prstGeom>
-          <a:noFill/>
-          <a:ln/>
-        </p:spPr>
-        <p:txBody>
-          <a:bodyPr wrap="square" lIns="0" tIns="0" rIns="0" bIns="0" rtlCol="0" anchor="t"/>
-          <a:lstStyle/>
-          <a:p>
-            <a:pPr indent="0" marL="0">
-              <a:buNone/>
-            </a:pPr>
-            <a:r>
-              <a:rPr lang="en-US" sz="1400" dirty="0">
-                <a:solidFill>
-                  <a:srgbClr val="E5D9C3"/>
-                </a:solidFill>
-                <a:latin typeface="Courier New" pitchFamily="34" charset="0"/>
-                <a:ea typeface="Courier New" pitchFamily="34" charset="-122"/>
-                <a:cs typeface="Courier New" pitchFamily="34" charset="-120"/>
-              </a:rPr>
-              <a:t>03</a:t>
-            </a:r>
-            <a:endParaRPr lang="en-US" sz="1400" dirty="0"/>
-          </a:p>
-        </p:txBody>
-      </p:sp>
-      <p:sp>
-        <p:nvSpPr>
-          <p:cNvPr id="14" name="Text 12"/>
-          <p:cNvSpPr txBox="1"/>
-          <p:nvPr/>
-        </p:nvSpPr>
-        <p:spPr>
-          <a:xfrm>
-            <a:off x="6949440" y="3895344"/>
-            <a:ext cx="4663440" cy="365760"/>
-          </a:xfrm>
-          <a:prstGeom prst="rect">
-            <a:avLst/>
-          </a:prstGeom>
-          <a:noFill/>
-          <a:ln/>
-        </p:spPr>
-        <p:txBody>
-          <a:bodyPr wrap="square" lIns="0" tIns="0" rIns="0" bIns="0" rtlCol="0" anchor="t"/>
-          <a:lstStyle/>
-          <a:p>
-            <a:pPr indent="0" marL="0">
-              <a:buNone/>
-            </a:pPr>
-            <a:r>
-              <a:rPr lang="en-US" sz="1900" b="1" dirty="0">
-                <a:solidFill>
-                  <a:srgbClr val="F3EFE7"/>
+              <a:t>¿Y si el resultado es desfavorable?</a:t>
+            </a:r>
+            <a:endParaRPr lang="en-US" sz="2000" dirty="0"/>
+          </a:p>
+        </p:txBody>
+      </p:sp>
+      <p:sp>
+        <p:nvSpPr>
+          <p:cNvPr id="18" name="Text 16"/>
+          <p:cNvSpPr txBox="1"/>
+          <p:nvPr/>
+        </p:nvSpPr>
+        <p:spPr>
+          <a:xfrm>
+            <a:off x="8421624" y="3703320"/>
+            <a:ext cx="2926080" cy="1371600"/>
+          </a:xfrm>
+          <a:prstGeom prst="rect">
+            <a:avLst/>
+          </a:prstGeom>
+          <a:noFill/>
+          <a:ln/>
+        </p:spPr>
+        <p:txBody>
+          <a:bodyPr wrap="square" lIns="0" tIns="0" rIns="0" bIns="0" rtlCol="0" anchor="t"/>
+          <a:lstStyle/>
+          <a:p>
+            <a:pPr indent="0" marL="0">
+              <a:lnSpc>
+                <a:spcPct val="120000"/>
+              </a:lnSpc>
+              <a:buNone/>
+            </a:pPr>
+            <a:r>
+              <a:rPr lang="en-US" sz="1500" dirty="0">
+                <a:solidFill>
+                  <a:srgbClr val="A39C90"/>
                 </a:solidFill>
                 <a:latin typeface="Calibri" pitchFamily="34" charset="0"/>
                 <a:ea typeface="Calibri" pitchFamily="34" charset="-122"/>
                 <a:cs typeface="Calibri" pitchFamily="34" charset="-120"/>
               </a:rPr>
-              <a:t>Aceptar el alcance</a:t>
-            </a:r>
-            <a:endParaRPr lang="en-US" sz="1900" dirty="0"/>
-          </a:p>
-        </p:txBody>
-      </p:sp>
-      <p:sp>
-        <p:nvSpPr>
-          <p:cNvPr id="15" name="Text 13"/>
-          <p:cNvSpPr txBox="1"/>
-          <p:nvPr/>
-        </p:nvSpPr>
-        <p:spPr>
-          <a:xfrm>
-            <a:off x="6949440" y="4306824"/>
-            <a:ext cx="4663440" cy="320040"/>
-          </a:xfrm>
-          <a:prstGeom prst="rect">
-            <a:avLst/>
-          </a:prstGeom>
-          <a:noFill/>
-          <a:ln/>
-        </p:spPr>
-        <p:txBody>
-          <a:bodyPr wrap="square" lIns="0" tIns="0" rIns="0" bIns="0" rtlCol="0" anchor="t"/>
-          <a:lstStyle/>
-          <a:p>
-            <a:pPr indent="0" marL="0">
-              <a:buNone/>
-            </a:pPr>
-            <a:r>
-              <a:rPr lang="en-US" sz="1400" dirty="0">
-                <a:solidFill>
-                  <a:srgbClr val="A39C90"/>
+              <a:t>Lo reportamos tal como es, con recomendaciones. Tú decides qué hacer y puedes pedir aclaraciones o retirar información.</a:t>
+            </a:r>
+            <a:endParaRPr lang="en-US" sz="1500" dirty="0"/>
+          </a:p>
+        </p:txBody>
+      </p:sp>
+      <p:sp>
+        <p:nvSpPr>
+          <p:cNvPr id="19" name="Text 17"/>
+          <p:cNvSpPr txBox="1"/>
+          <p:nvPr/>
+        </p:nvSpPr>
+        <p:spPr>
+          <a:xfrm>
+            <a:off x="548640" y="5486400"/>
+            <a:ext cx="10972800" cy="457200"/>
+          </a:xfrm>
+          <a:prstGeom prst="rect">
+            <a:avLst/>
+          </a:prstGeom>
+          <a:noFill/>
+          <a:ln/>
+        </p:spPr>
+        <p:txBody>
+          <a:bodyPr wrap="square" lIns="0" tIns="0" rIns="0" bIns="0" rtlCol="0" anchor="t"/>
+          <a:lstStyle/>
+          <a:p>
+            <a:pPr indent="0" marL="0">
+              <a:buNone/>
+            </a:pPr>
+            <a:r>
+              <a:rPr lang="en-US" sz="1500" b="1" dirty="0">
+                <a:solidFill>
+                  <a:srgbClr val="E5D9C3"/>
                 </a:solidFill>
                 <a:latin typeface="Calibri" pitchFamily="34" charset="0"/>
                 <a:ea typeface="Calibri" pitchFamily="34" charset="-122"/>
                 <a:cs typeface="Calibri" pitchFamily="34" charset="-120"/>
               </a:rPr>
-              <a:t>Lo que recibe y lo que no, por escrito</a:t>
-            </a:r>
-            <a:endParaRPr lang="en-US" sz="1400" dirty="0"/>
-          </a:p>
-        </p:txBody>
-      </p:sp>
-      <p:sp>
-        <p:nvSpPr>
-          <p:cNvPr id="16" name="Shape 14"/>
-          <p:cNvSpPr/>
-          <p:nvPr/>
-        </p:nvSpPr>
-        <p:spPr>
-          <a:xfrm>
-            <a:off x="6309360" y="4764024"/>
-            <a:ext cx="5349240" cy="0"/>
-          </a:xfrm>
-          <a:prstGeom prst="line">
-            <a:avLst/>
-          </a:prstGeom>
-          <a:noFill/>
-          <a:ln w="9525">
-            <a:solidFill>
-              <a:srgbClr val="2E2B27"/>
-            </a:solidFill>
-            <a:prstDash val="solid"/>
-          </a:ln>
-        </p:spPr>
-      </p:sp>
-      <p:sp>
-        <p:nvSpPr>
-          <p:cNvPr id="17" name="Text 15"/>
-          <p:cNvSpPr txBox="1"/>
-          <p:nvPr/>
-        </p:nvSpPr>
-        <p:spPr>
-          <a:xfrm>
-            <a:off x="6309360" y="4882896"/>
-            <a:ext cx="548640" cy="365760"/>
-          </a:xfrm>
-          <a:prstGeom prst="rect">
-            <a:avLst/>
-          </a:prstGeom>
-          <a:noFill/>
-          <a:ln/>
-        </p:spPr>
-        <p:txBody>
-          <a:bodyPr wrap="square" lIns="0" tIns="0" rIns="0" bIns="0" rtlCol="0" anchor="t"/>
-          <a:lstStyle/>
-          <a:p>
-            <a:pPr indent="0" marL="0">
-              <a:buNone/>
-            </a:pPr>
-            <a:r>
-              <a:rPr lang="en-US" sz="1400" dirty="0">
-                <a:solidFill>
-                  <a:srgbClr val="E5D9C3"/>
-                </a:solidFill>
-                <a:latin typeface="Courier New" pitchFamily="34" charset="0"/>
-                <a:ea typeface="Courier New" pitchFamily="34" charset="-122"/>
-                <a:cs typeface="Courier New" pitchFamily="34" charset="-120"/>
-              </a:rPr>
-              <a:t>04</a:t>
-            </a:r>
-            <a:endParaRPr lang="en-US" sz="1400" dirty="0"/>
-          </a:p>
-        </p:txBody>
-      </p:sp>
-      <p:sp>
-        <p:nvSpPr>
-          <p:cNvPr id="18" name="Text 16"/>
-          <p:cNvSpPr txBox="1"/>
-          <p:nvPr/>
-        </p:nvSpPr>
-        <p:spPr>
-          <a:xfrm>
-            <a:off x="6949440" y="4882896"/>
-            <a:ext cx="4663440" cy="365760"/>
-          </a:xfrm>
-          <a:prstGeom prst="rect">
-            <a:avLst/>
-          </a:prstGeom>
-          <a:noFill/>
-          <a:ln/>
-        </p:spPr>
-        <p:txBody>
-          <a:bodyPr wrap="square" lIns="0" tIns="0" rIns="0" bIns="0" rtlCol="0" anchor="t"/>
-          <a:lstStyle/>
-          <a:p>
-            <a:pPr indent="0" marL="0">
-              <a:buNone/>
-            </a:pPr>
-            <a:r>
-              <a:rPr lang="en-US" sz="1900" b="1" dirty="0">
-                <a:solidFill>
-                  <a:srgbClr val="F3EFE7"/>
+              <a:t>Consentimiento informado: </a:t>
+            </a:r>
+            <a:pPr indent="0" marL="0">
+              <a:buNone/>
+            </a:pPr>
+            <a:r>
+              <a:rPr lang="en-US" sz="1500" dirty="0">
+                <a:solidFill>
+                  <a:srgbClr val="D9D3C8"/>
                 </a:solidFill>
                 <a:latin typeface="Calibri" pitchFamily="34" charset="0"/>
                 <a:ea typeface="Calibri" pitchFamily="34" charset="-122"/>
                 <a:cs typeface="Calibri" pitchFamily="34" charset="-120"/>
               </a:rPr>
-              <a:t>Agendar la sesión de TA1</a:t>
-            </a:r>
-            <a:endParaRPr lang="en-US" sz="1900" dirty="0"/>
-          </a:p>
-        </p:txBody>
-      </p:sp>
-      <p:sp>
-        <p:nvSpPr>
-          <p:cNvPr id="19" name="Text 17"/>
-          <p:cNvSpPr txBox="1"/>
-          <p:nvPr/>
-        </p:nvSpPr>
-        <p:spPr>
-          <a:xfrm>
-            <a:off x="6949440" y="5294376"/>
-            <a:ext cx="4663440" cy="320040"/>
-          </a:xfrm>
-          <a:prstGeom prst="rect">
-            <a:avLst/>
-          </a:prstGeom>
-          <a:noFill/>
-          <a:ln/>
-        </p:spPr>
-        <p:txBody>
-          <a:bodyPr wrap="square" lIns="0" tIns="0" rIns="0" bIns="0" rtlCol="0" anchor="t"/>
-          <a:lstStyle/>
-          <a:p>
-            <a:pPr indent="0" marL="0">
-              <a:buNone/>
-            </a:pPr>
-            <a:r>
-              <a:rPr lang="en-US" sz="1400" dirty="0">
-                <a:solidFill>
-                  <a:srgbClr val="A39C90"/>
-                </a:solidFill>
-                <a:latin typeface="Calibri" pitchFamily="34" charset="0"/>
-                <a:ea typeface="Calibri" pitchFamily="34" charset="-122"/>
-                <a:cs typeface="Calibri" pitchFamily="34" charset="-120"/>
-              </a:rPr>
-              <a:t>Semana del 2 de noviembre, por Meet</a:t>
-            </a:r>
-            <a:endParaRPr lang="en-US" sz="1400" dirty="0"/>
+              <a:t>con tu aceptación del alcance confirmas que conoces y aceptas este manejo de la información.</a:t>
+            </a:r>
+            <a:endParaRPr lang="en-US" sz="1500" dirty="0"/>
           </a:p>
         </p:txBody>
       </p:sp>
@@ -3838,6 +3918,736 @@
           <a:chExt cx="0" cy="0"/>
         </a:xfrm>
       </p:grpSpPr>
+      <p:sp>
+        <p:nvSpPr>
+          <p:cNvPr id="2" name="Text 0"/>
+          <p:cNvSpPr txBox="1"/>
+          <p:nvPr/>
+        </p:nvSpPr>
+        <p:spPr>
+          <a:xfrm>
+            <a:off x="548640" y="502920"/>
+            <a:ext cx="9144000" cy="320040"/>
+          </a:xfrm>
+          <a:prstGeom prst="rect">
+            <a:avLst/>
+          </a:prstGeom>
+          <a:noFill/>
+          <a:ln/>
+        </p:spPr>
+        <p:txBody>
+          <a:bodyPr wrap="square" lIns="0" tIns="0" rIns="0" bIns="0" rtlCol="0" anchor="t"/>
+          <a:lstStyle/>
+          <a:p>
+            <a:pPr indent="0" marL="0">
+              <a:buNone/>
+            </a:pPr>
+            <a:r>
+              <a:rPr lang="en-US" sz="1300" spc="300" kern="0" dirty="0">
+                <a:solidFill>
+                  <a:srgbClr val="9C8A6B"/>
+                </a:solidFill>
+                <a:latin typeface="Courier New" pitchFamily="34" charset="0"/>
+                <a:ea typeface="Courier New" pitchFamily="34" charset="-122"/>
+                <a:cs typeface="Courier New" pitchFamily="34" charset="-120"/>
+              </a:rPr>
+              <a:t>11 · PRÓXIMOS PASOS</a:t>
+            </a:r>
+            <a:endParaRPr lang="en-US" sz="1300" dirty="0"/>
+          </a:p>
+        </p:txBody>
+      </p:sp>
+      <p:sp>
+        <p:nvSpPr>
+          <p:cNvPr id="3" name="Text 1"/>
+          <p:cNvSpPr txBox="1"/>
+          <p:nvPr/>
+        </p:nvSpPr>
+        <p:spPr>
+          <a:xfrm>
+            <a:off x="548640" y="868680"/>
+            <a:ext cx="10972800" cy="777240"/>
+          </a:xfrm>
+          <a:prstGeom prst="rect">
+            <a:avLst/>
+          </a:prstGeom>
+          <a:noFill/>
+          <a:ln/>
+        </p:spPr>
+        <p:txBody>
+          <a:bodyPr wrap="square" lIns="0" tIns="0" rIns="0" bIns="0" rtlCol="0" anchor="t"/>
+          <a:lstStyle/>
+          <a:p>
+            <a:pPr indent="0" marL="0">
+              <a:buNone/>
+            </a:pPr>
+            <a:r>
+              <a:rPr lang="en-US" sz="4000" dirty="0">
+                <a:solidFill>
+                  <a:srgbClr val="F3EFE7"/>
+                </a:solidFill>
+                <a:latin typeface="Calibri" pitchFamily="34" charset="0"/>
+                <a:ea typeface="Calibri" pitchFamily="34" charset="-122"/>
+                <a:cs typeface="Calibri" pitchFamily="34" charset="-120"/>
+              </a:rPr>
+              <a:t>Lo que necesitamos de TALENT</a:t>
+            </a:r>
+            <a:endParaRPr lang="en-US" sz="4000" dirty="0"/>
+          </a:p>
+        </p:txBody>
+      </p:sp>
+      <p:sp>
+        <p:nvSpPr>
+          <p:cNvPr id="4" name="Text 2"/>
+          <p:cNvSpPr txBox="1"/>
+          <p:nvPr/>
+        </p:nvSpPr>
+        <p:spPr>
+          <a:xfrm>
+            <a:off x="548640" y="1920240"/>
+            <a:ext cx="4846320" cy="1463040"/>
+          </a:xfrm>
+          <a:prstGeom prst="rect">
+            <a:avLst/>
+          </a:prstGeom>
+          <a:noFill/>
+          <a:ln/>
+        </p:spPr>
+        <p:txBody>
+          <a:bodyPr wrap="square" lIns="0" tIns="0" rIns="0" bIns="0" rtlCol="0" anchor="t"/>
+          <a:lstStyle/>
+          <a:p>
+            <a:pPr indent="0" marL="0">
+              <a:lnSpc>
+                <a:spcPct val="120000"/>
+              </a:lnSpc>
+              <a:buNone/>
+            </a:pPr>
+            <a:r>
+              <a:rPr lang="en-US" sz="2000" dirty="0">
+                <a:solidFill>
+                  <a:srgbClr val="D9D3C8"/>
+                </a:solidFill>
+                <a:latin typeface="Calibri" pitchFamily="34" charset="0"/>
+                <a:ea typeface="Calibri" pitchFamily="34" charset="-122"/>
+                <a:cs typeface="Calibri" pitchFamily="34" charset="-120"/>
+              </a:rPr>
+              <a:t>Para empezar TA1 el 2 de noviembre, pedimos a la fundadora estos soportes y su aceptación del alcance.</a:t>
+            </a:r>
+            <a:endParaRPr lang="en-US" sz="2000" dirty="0"/>
+          </a:p>
+        </p:txBody>
+      </p:sp>
+      <p:sp>
+        <p:nvSpPr>
+          <p:cNvPr id="5" name="Text 3"/>
+          <p:cNvSpPr txBox="1"/>
+          <p:nvPr/>
+        </p:nvSpPr>
+        <p:spPr>
+          <a:xfrm>
+            <a:off x="6309360" y="1920240"/>
+            <a:ext cx="548640" cy="365760"/>
+          </a:xfrm>
+          <a:prstGeom prst="rect">
+            <a:avLst/>
+          </a:prstGeom>
+          <a:noFill/>
+          <a:ln/>
+        </p:spPr>
+        <p:txBody>
+          <a:bodyPr wrap="square" lIns="0" tIns="0" rIns="0" bIns="0" rtlCol="0" anchor="t"/>
+          <a:lstStyle/>
+          <a:p>
+            <a:pPr indent="0" marL="0">
+              <a:buNone/>
+            </a:pPr>
+            <a:r>
+              <a:rPr lang="en-US" sz="1400" dirty="0">
+                <a:solidFill>
+                  <a:srgbClr val="E5D9C3"/>
+                </a:solidFill>
+                <a:latin typeface="Courier New" pitchFamily="34" charset="0"/>
+                <a:ea typeface="Courier New" pitchFamily="34" charset="-122"/>
+                <a:cs typeface="Courier New" pitchFamily="34" charset="-120"/>
+              </a:rPr>
+              <a:t>01</a:t>
+            </a:r>
+            <a:endParaRPr lang="en-US" sz="1400" dirty="0"/>
+          </a:p>
+        </p:txBody>
+      </p:sp>
+      <p:sp>
+        <p:nvSpPr>
+          <p:cNvPr id="6" name="Text 4"/>
+          <p:cNvSpPr txBox="1"/>
+          <p:nvPr/>
+        </p:nvSpPr>
+        <p:spPr>
+          <a:xfrm>
+            <a:off x="6949440" y="1920240"/>
+            <a:ext cx="4663440" cy="365760"/>
+          </a:xfrm>
+          <a:prstGeom prst="rect">
+            <a:avLst/>
+          </a:prstGeom>
+          <a:noFill/>
+          <a:ln/>
+        </p:spPr>
+        <p:txBody>
+          <a:bodyPr wrap="square" lIns="0" tIns="0" rIns="0" bIns="0" rtlCol="0" anchor="t"/>
+          <a:lstStyle/>
+          <a:p>
+            <a:pPr indent="0" marL="0">
+              <a:buNone/>
+            </a:pPr>
+            <a:r>
+              <a:rPr lang="en-US" sz="1900" b="1" dirty="0">
+                <a:solidFill>
+                  <a:srgbClr val="F3EFE7"/>
+                </a:solidFill>
+                <a:latin typeface="Calibri" pitchFamily="34" charset="0"/>
+                <a:ea typeface="Calibri" pitchFamily="34" charset="-122"/>
+                <a:cs typeface="Calibri" pitchFamily="34" charset="-120"/>
+              </a:rPr>
+              <a:t>Firmar el acta del diagnóstico</a:t>
+            </a:r>
+            <a:endParaRPr lang="en-US" sz="1900" dirty="0"/>
+          </a:p>
+        </p:txBody>
+      </p:sp>
+      <p:sp>
+        <p:nvSpPr>
+          <p:cNvPr id="7" name="Text 5"/>
+          <p:cNvSpPr txBox="1"/>
+          <p:nvPr/>
+        </p:nvSpPr>
+        <p:spPr>
+          <a:xfrm>
+            <a:off x="6949440" y="2331720"/>
+            <a:ext cx="4663440" cy="320040"/>
+          </a:xfrm>
+          <a:prstGeom prst="rect">
+            <a:avLst/>
+          </a:prstGeom>
+          <a:noFill/>
+          <a:ln/>
+        </p:spPr>
+        <p:txBody>
+          <a:bodyPr wrap="square" lIns="0" tIns="0" rIns="0" bIns="0" rtlCol="0" anchor="t"/>
+          <a:lstStyle/>
+          <a:p>
+            <a:pPr indent="0" marL="0">
+              <a:buNone/>
+            </a:pPr>
+            <a:r>
+              <a:rPr lang="en-US" sz="1400" dirty="0">
+                <a:solidFill>
+                  <a:srgbClr val="A39C90"/>
+                </a:solidFill>
+                <a:latin typeface="Calibri" pitchFamily="34" charset="0"/>
+                <a:ea typeface="Calibri" pitchFamily="34" charset="-122"/>
+                <a:cs typeface="Calibri" pitchFamily="34" charset="-120"/>
+              </a:rPr>
+              <a:t>Confirma las respuestas del 27 de octubre</a:t>
+            </a:r>
+            <a:endParaRPr lang="en-US" sz="1400" dirty="0"/>
+          </a:p>
+        </p:txBody>
+      </p:sp>
+      <p:sp>
+        <p:nvSpPr>
+          <p:cNvPr id="8" name="Shape 6"/>
+          <p:cNvSpPr/>
+          <p:nvPr/>
+        </p:nvSpPr>
+        <p:spPr>
+          <a:xfrm>
+            <a:off x="6309360" y="2788920"/>
+            <a:ext cx="5349240" cy="0"/>
+          </a:xfrm>
+          <a:prstGeom prst="line">
+            <a:avLst/>
+          </a:prstGeom>
+          <a:noFill/>
+          <a:ln w="9525">
+            <a:solidFill>
+              <a:srgbClr val="2E2B27"/>
+            </a:solidFill>
+            <a:prstDash val="solid"/>
+          </a:ln>
+        </p:spPr>
+      </p:sp>
+      <p:sp>
+        <p:nvSpPr>
+          <p:cNvPr id="9" name="Text 7"/>
+          <p:cNvSpPr txBox="1"/>
+          <p:nvPr/>
+        </p:nvSpPr>
+        <p:spPr>
+          <a:xfrm>
+            <a:off x="6309360" y="2907792"/>
+            <a:ext cx="548640" cy="365760"/>
+          </a:xfrm>
+          <a:prstGeom prst="rect">
+            <a:avLst/>
+          </a:prstGeom>
+          <a:noFill/>
+          <a:ln/>
+        </p:spPr>
+        <p:txBody>
+          <a:bodyPr wrap="square" lIns="0" tIns="0" rIns="0" bIns="0" rtlCol="0" anchor="t"/>
+          <a:lstStyle/>
+          <a:p>
+            <a:pPr indent="0" marL="0">
+              <a:buNone/>
+            </a:pPr>
+            <a:r>
+              <a:rPr lang="en-US" sz="1400" dirty="0">
+                <a:solidFill>
+                  <a:srgbClr val="E5D9C3"/>
+                </a:solidFill>
+                <a:latin typeface="Courier New" pitchFamily="34" charset="0"/>
+                <a:ea typeface="Courier New" pitchFamily="34" charset="-122"/>
+                <a:cs typeface="Courier New" pitchFamily="34" charset="-120"/>
+              </a:rPr>
+              <a:t>02</a:t>
+            </a:r>
+            <a:endParaRPr lang="en-US" sz="1400" dirty="0"/>
+          </a:p>
+        </p:txBody>
+      </p:sp>
+      <p:sp>
+        <p:nvSpPr>
+          <p:cNvPr id="10" name="Text 8"/>
+          <p:cNvSpPr txBox="1"/>
+          <p:nvPr/>
+        </p:nvSpPr>
+        <p:spPr>
+          <a:xfrm>
+            <a:off x="6949440" y="2907792"/>
+            <a:ext cx="4663440" cy="365760"/>
+          </a:xfrm>
+          <a:prstGeom prst="rect">
+            <a:avLst/>
+          </a:prstGeom>
+          <a:noFill/>
+          <a:ln/>
+        </p:spPr>
+        <p:txBody>
+          <a:bodyPr wrap="square" lIns="0" tIns="0" rIns="0" bIns="0" rtlCol="0" anchor="t"/>
+          <a:lstStyle/>
+          <a:p>
+            <a:pPr indent="0" marL="0">
+              <a:buNone/>
+            </a:pPr>
+            <a:r>
+              <a:rPr lang="en-US" sz="1900" b="1" dirty="0">
+                <a:solidFill>
+                  <a:srgbClr val="F3EFE7"/>
+                </a:solidFill>
+                <a:latin typeface="Calibri" pitchFamily="34" charset="0"/>
+                <a:ea typeface="Calibri" pitchFamily="34" charset="-122"/>
+                <a:cs typeface="Calibri" pitchFamily="34" charset="-120"/>
+              </a:rPr>
+              <a:t>Compartir los soportes</a:t>
+            </a:r>
+            <a:endParaRPr lang="en-US" sz="1900" dirty="0"/>
+          </a:p>
+        </p:txBody>
+      </p:sp>
+      <p:sp>
+        <p:nvSpPr>
+          <p:cNvPr id="11" name="Text 9"/>
+          <p:cNvSpPr txBox="1"/>
+          <p:nvPr/>
+        </p:nvSpPr>
+        <p:spPr>
+          <a:xfrm>
+            <a:off x="6949440" y="3319272"/>
+            <a:ext cx="4663440" cy="320040"/>
+          </a:xfrm>
+          <a:prstGeom prst="rect">
+            <a:avLst/>
+          </a:prstGeom>
+          <a:noFill/>
+          <a:ln/>
+        </p:spPr>
+        <p:txBody>
+          <a:bodyPr wrap="square" lIns="0" tIns="0" rIns="0" bIns="0" rtlCol="0" anchor="t"/>
+          <a:lstStyle/>
+          <a:p>
+            <a:pPr indent="0" marL="0">
+              <a:buNone/>
+            </a:pPr>
+            <a:r>
+              <a:rPr lang="en-US" sz="1400" dirty="0">
+                <a:solidFill>
+                  <a:srgbClr val="A39C90"/>
+                </a:solidFill>
+                <a:latin typeface="Calibri" pitchFamily="34" charset="0"/>
+                <a:ea typeface="Calibri" pitchFamily="34" charset="-122"/>
+                <a:cs typeface="Calibri" pitchFamily="34" charset="-120"/>
+              </a:rPr>
+              <a:t>RUT, planilla PILA y licencia SST de la aliada</a:t>
+            </a:r>
+            <a:endParaRPr lang="en-US" sz="1400" dirty="0"/>
+          </a:p>
+        </p:txBody>
+      </p:sp>
+      <p:sp>
+        <p:nvSpPr>
+          <p:cNvPr id="12" name="Shape 10"/>
+          <p:cNvSpPr/>
+          <p:nvPr/>
+        </p:nvSpPr>
+        <p:spPr>
+          <a:xfrm>
+            <a:off x="6309360" y="3776472"/>
+            <a:ext cx="5349240" cy="0"/>
+          </a:xfrm>
+          <a:prstGeom prst="line">
+            <a:avLst/>
+          </a:prstGeom>
+          <a:noFill/>
+          <a:ln w="9525">
+            <a:solidFill>
+              <a:srgbClr val="2E2B27"/>
+            </a:solidFill>
+            <a:prstDash val="solid"/>
+          </a:ln>
+        </p:spPr>
+      </p:sp>
+      <p:sp>
+        <p:nvSpPr>
+          <p:cNvPr id="13" name="Text 11"/>
+          <p:cNvSpPr txBox="1"/>
+          <p:nvPr/>
+        </p:nvSpPr>
+        <p:spPr>
+          <a:xfrm>
+            <a:off x="6309360" y="3895344"/>
+            <a:ext cx="548640" cy="365760"/>
+          </a:xfrm>
+          <a:prstGeom prst="rect">
+            <a:avLst/>
+          </a:prstGeom>
+          <a:noFill/>
+          <a:ln/>
+        </p:spPr>
+        <p:txBody>
+          <a:bodyPr wrap="square" lIns="0" tIns="0" rIns="0" bIns="0" rtlCol="0" anchor="t"/>
+          <a:lstStyle/>
+          <a:p>
+            <a:pPr indent="0" marL="0">
+              <a:buNone/>
+            </a:pPr>
+            <a:r>
+              <a:rPr lang="en-US" sz="1400" dirty="0">
+                <a:solidFill>
+                  <a:srgbClr val="E5D9C3"/>
+                </a:solidFill>
+                <a:latin typeface="Courier New" pitchFamily="34" charset="0"/>
+                <a:ea typeface="Courier New" pitchFamily="34" charset="-122"/>
+                <a:cs typeface="Courier New" pitchFamily="34" charset="-120"/>
+              </a:rPr>
+              <a:t>03</a:t>
+            </a:r>
+            <a:endParaRPr lang="en-US" sz="1400" dirty="0"/>
+          </a:p>
+        </p:txBody>
+      </p:sp>
+      <p:sp>
+        <p:nvSpPr>
+          <p:cNvPr id="14" name="Text 12"/>
+          <p:cNvSpPr txBox="1"/>
+          <p:nvPr/>
+        </p:nvSpPr>
+        <p:spPr>
+          <a:xfrm>
+            <a:off x="6949440" y="3895344"/>
+            <a:ext cx="4663440" cy="365760"/>
+          </a:xfrm>
+          <a:prstGeom prst="rect">
+            <a:avLst/>
+          </a:prstGeom>
+          <a:noFill/>
+          <a:ln/>
+        </p:spPr>
+        <p:txBody>
+          <a:bodyPr wrap="square" lIns="0" tIns="0" rIns="0" bIns="0" rtlCol="0" anchor="t"/>
+          <a:lstStyle/>
+          <a:p>
+            <a:pPr indent="0" marL="0">
+              <a:buNone/>
+            </a:pPr>
+            <a:r>
+              <a:rPr lang="en-US" sz="1900" b="1" dirty="0">
+                <a:solidFill>
+                  <a:srgbClr val="F3EFE7"/>
+                </a:solidFill>
+                <a:latin typeface="Calibri" pitchFamily="34" charset="0"/>
+                <a:ea typeface="Calibri" pitchFamily="34" charset="-122"/>
+                <a:cs typeface="Calibri" pitchFamily="34" charset="-120"/>
+              </a:rPr>
+              <a:t>Aceptar alcance y uso de datos</a:t>
+            </a:r>
+            <a:endParaRPr lang="en-US" sz="1900" dirty="0"/>
+          </a:p>
+        </p:txBody>
+      </p:sp>
+      <p:sp>
+        <p:nvSpPr>
+          <p:cNvPr id="15" name="Text 13"/>
+          <p:cNvSpPr txBox="1"/>
+          <p:nvPr/>
+        </p:nvSpPr>
+        <p:spPr>
+          <a:xfrm>
+            <a:off x="6949440" y="4306824"/>
+            <a:ext cx="4663440" cy="320040"/>
+          </a:xfrm>
+          <a:prstGeom prst="rect">
+            <a:avLst/>
+          </a:prstGeom>
+          <a:noFill/>
+          <a:ln/>
+        </p:spPr>
+        <p:txBody>
+          <a:bodyPr wrap="square" lIns="0" tIns="0" rIns="0" bIns="0" rtlCol="0" anchor="t"/>
+          <a:lstStyle/>
+          <a:p>
+            <a:pPr indent="0" marL="0">
+              <a:buNone/>
+            </a:pPr>
+            <a:r>
+              <a:rPr lang="en-US" sz="1400" dirty="0">
+                <a:solidFill>
+                  <a:srgbClr val="A39C90"/>
+                </a:solidFill>
+                <a:latin typeface="Calibri" pitchFamily="34" charset="0"/>
+                <a:ea typeface="Calibri" pitchFamily="34" charset="-122"/>
+                <a:cs typeface="Calibri" pitchFamily="34" charset="-120"/>
+              </a:rPr>
+              <a:t>Lo que recibe, lo que no y cómo cuidamos su información</a:t>
+            </a:r>
+            <a:endParaRPr lang="en-US" sz="1400" dirty="0"/>
+          </a:p>
+        </p:txBody>
+      </p:sp>
+      <p:sp>
+        <p:nvSpPr>
+          <p:cNvPr id="16" name="Shape 14"/>
+          <p:cNvSpPr/>
+          <p:nvPr/>
+        </p:nvSpPr>
+        <p:spPr>
+          <a:xfrm>
+            <a:off x="6309360" y="4764024"/>
+            <a:ext cx="5349240" cy="0"/>
+          </a:xfrm>
+          <a:prstGeom prst="line">
+            <a:avLst/>
+          </a:prstGeom>
+          <a:noFill/>
+          <a:ln w="9525">
+            <a:solidFill>
+              <a:srgbClr val="2E2B27"/>
+            </a:solidFill>
+            <a:prstDash val="solid"/>
+          </a:ln>
+        </p:spPr>
+      </p:sp>
+      <p:sp>
+        <p:nvSpPr>
+          <p:cNvPr id="17" name="Text 15"/>
+          <p:cNvSpPr txBox="1"/>
+          <p:nvPr/>
+        </p:nvSpPr>
+        <p:spPr>
+          <a:xfrm>
+            <a:off x="6309360" y="4882896"/>
+            <a:ext cx="548640" cy="365760"/>
+          </a:xfrm>
+          <a:prstGeom prst="rect">
+            <a:avLst/>
+          </a:prstGeom>
+          <a:noFill/>
+          <a:ln/>
+        </p:spPr>
+        <p:txBody>
+          <a:bodyPr wrap="square" lIns="0" tIns="0" rIns="0" bIns="0" rtlCol="0" anchor="t"/>
+          <a:lstStyle/>
+          <a:p>
+            <a:pPr indent="0" marL="0">
+              <a:buNone/>
+            </a:pPr>
+            <a:r>
+              <a:rPr lang="en-US" sz="1400" dirty="0">
+                <a:solidFill>
+                  <a:srgbClr val="E5D9C3"/>
+                </a:solidFill>
+                <a:latin typeface="Courier New" pitchFamily="34" charset="0"/>
+                <a:ea typeface="Courier New" pitchFamily="34" charset="-122"/>
+                <a:cs typeface="Courier New" pitchFamily="34" charset="-120"/>
+              </a:rPr>
+              <a:t>04</a:t>
+            </a:r>
+            <a:endParaRPr lang="en-US" sz="1400" dirty="0"/>
+          </a:p>
+        </p:txBody>
+      </p:sp>
+      <p:sp>
+        <p:nvSpPr>
+          <p:cNvPr id="18" name="Text 16"/>
+          <p:cNvSpPr txBox="1"/>
+          <p:nvPr/>
+        </p:nvSpPr>
+        <p:spPr>
+          <a:xfrm>
+            <a:off x="6949440" y="4882896"/>
+            <a:ext cx="4663440" cy="365760"/>
+          </a:xfrm>
+          <a:prstGeom prst="rect">
+            <a:avLst/>
+          </a:prstGeom>
+          <a:noFill/>
+          <a:ln/>
+        </p:spPr>
+        <p:txBody>
+          <a:bodyPr wrap="square" lIns="0" tIns="0" rIns="0" bIns="0" rtlCol="0" anchor="t"/>
+          <a:lstStyle/>
+          <a:p>
+            <a:pPr indent="0" marL="0">
+              <a:buNone/>
+            </a:pPr>
+            <a:r>
+              <a:rPr lang="en-US" sz="1900" b="1" dirty="0">
+                <a:solidFill>
+                  <a:srgbClr val="F3EFE7"/>
+                </a:solidFill>
+                <a:latin typeface="Calibri" pitchFamily="34" charset="0"/>
+                <a:ea typeface="Calibri" pitchFamily="34" charset="-122"/>
+                <a:cs typeface="Calibri" pitchFamily="34" charset="-120"/>
+              </a:rPr>
+              <a:t>Agendar la sesión de TA1</a:t>
+            </a:r>
+            <a:endParaRPr lang="en-US" sz="1900" dirty="0"/>
+          </a:p>
+        </p:txBody>
+      </p:sp>
+      <p:sp>
+        <p:nvSpPr>
+          <p:cNvPr id="19" name="Text 17"/>
+          <p:cNvSpPr txBox="1"/>
+          <p:nvPr/>
+        </p:nvSpPr>
+        <p:spPr>
+          <a:xfrm>
+            <a:off x="6949440" y="5294376"/>
+            <a:ext cx="4663440" cy="320040"/>
+          </a:xfrm>
+          <a:prstGeom prst="rect">
+            <a:avLst/>
+          </a:prstGeom>
+          <a:noFill/>
+          <a:ln/>
+        </p:spPr>
+        <p:txBody>
+          <a:bodyPr wrap="square" lIns="0" tIns="0" rIns="0" bIns="0" rtlCol="0" anchor="t"/>
+          <a:lstStyle/>
+          <a:p>
+            <a:pPr indent="0" marL="0">
+              <a:buNone/>
+            </a:pPr>
+            <a:r>
+              <a:rPr lang="en-US" sz="1400" dirty="0">
+                <a:solidFill>
+                  <a:srgbClr val="A39C90"/>
+                </a:solidFill>
+                <a:latin typeface="Calibri" pitchFamily="34" charset="0"/>
+                <a:ea typeface="Calibri" pitchFamily="34" charset="-122"/>
+                <a:cs typeface="Calibri" pitchFamily="34" charset="-120"/>
+              </a:rPr>
+              <a:t>Semana del 2 de noviembre, por Meet</a:t>
+            </a:r>
+            <a:endParaRPr lang="en-US" sz="1400" dirty="0"/>
+          </a:p>
+        </p:txBody>
+      </p:sp>
+      <p:sp>
+        <p:nvSpPr>
+          <p:cNvPr id="25" name="Slide Number Placeholder 0"/>
+          <p:cNvSpPr>
+            <a:spLocks noGrp="1"/>
+          </p:cNvSpPr>
+          <p:nvPr>
+            <p:ph type="sldNum" sz="quarter" idx="4294967295"/>
+          </p:nvPr>
+        </p:nvSpPr>
+        <p:spPr>
+          <a:xfrm>
+            <a:off x="11155680" y="6355080"/>
+            <a:ext cx="548640" cy="274320"/>
+          </a:xfrm>
+          <a:prstGeom prst="rect">
+            <a:avLst/>
+          </a:prstGeom>
+          <a:extLst>
+            <a:ext uri="{C572A759-6A51-4108-AA02-DFA0A04FC94B}">
+              <ma14:wrappingTextBoxFlag xmlns:ma14="http://schemas.microsoft.com/office/mac/drawingml/2011/main" val="0"/>
+            </a:ext>
+          </a:extLst>
+        </p:spPr>
+        <p:txBody>
+          <a:bodyPr/>
+          <a:lstStyle>
+            <a:lvl1pPr>
+              <a:defRPr sz="1000">
+                <a:solidFill>
+                  <a:srgbClr val="6E675C"/>
+                </a:solidFill>
+                <a:latin typeface="Courier New"/>
+                <a:ea typeface="Courier New"/>
+                <a:cs typeface="Courier New"/>
+              </a:defRPr>
+            </a:lvl1pPr>
+          </a:lstStyle>
+          <a:p>
+            <a:pPr algn="r"/>
+            <a:fld id="{F7021451-1387-4CA6-816F-3879F97B5CBC}" type="slidenum">
+              <a:rPr b="0" lang="en-US"/>
+              <a:t>12</a:t>
+            </a:fld>
+            <a:endParaRPr lang="en-US"/>
+          </a:p>
+        </p:txBody>
+      </p:sp>
+    </p:spTree>
+  </p:cSld>
+  <p:clrMapOvr>
+    <a:masterClrMapping/>
+  </p:clrMapOvr>
+</p:sld>
+</file>
+
+<file path=ppt/slides/slide13.xml><?xml version="1.0" encoding="utf-8"?>
+<p:sld xmlns:a="http://schemas.openxmlformats.org/drawingml/2006/main" xmlns:r="http://schemas.openxmlformats.org/officeDocument/2006/relationships" xmlns:p="http://schemas.openxmlformats.org/presentationml/2006/main">
+  <p:cSld name="Slide 13">
+    <p:spTree>
+      <p:nvGrpSpPr>
+        <p:cNvPr id="1" name=""/>
+        <p:cNvGrpSpPr/>
+        <p:nvPr/>
+      </p:nvGrpSpPr>
+      <p:grpSpPr>
+        <a:xfrm>
+          <a:off x="0" y="0"/>
+          <a:ext cx="0" cy="0"/>
+          <a:chOff x="0" y="0"/>
+          <a:chExt cx="0" cy="0"/>
+        </a:xfrm>
+      </p:grpSpPr>
       <p:pic>
         <p:nvPicPr>
           <p:cNvPr id="2" name="Image 0" descr="iso.jpg">    </p:cNvPr>
@@ -4021,7 +4831,7 @@
             <a:pPr algn="r"/>
             <a:fld id="{F7021451-1387-4CA6-816F-3879F97B5CBC}" type="slidenum">
               <a:rPr b="0" lang="en-US"/>
-              <a:t>12</a:t>
+              <a:t>13</a:t>
             </a:fld>
             <a:endParaRPr lang="en-US"/>
           </a:p>
@@ -11323,7 +12133,7 @@
                 <a:ea typeface="Courier New" pitchFamily="34" charset="-122"/>
                 <a:cs typeface="Courier New" pitchFamily="34" charset="-120"/>
               </a:rPr>
-              <a:t>Semana 8 · 7–11 dic</a:t>
+              <a:t>Semanas 7–8 · 30 nov–11 dic</a:t>
             </a:r>
             <a:endParaRPr lang="en-US" sz="1100" dirty="0"/>
           </a:p>
@@ -11443,7 +12253,7 @@
                 <a:ea typeface="Calibri" pitchFamily="34" charset="-122"/>
                 <a:cs typeface="Calibri" pitchFamily="34" charset="-120"/>
               </a:rPr>
-              <a:t>Entrega final de la consultoría a TALENT</a:t>
+              <a:t>Se prepara desde la semana 7 y se entrega a TALENT en la semana 8</a:t>
             </a:r>
             <a:endParaRPr lang="en-US" sz="1400" dirty="0"/>
           </a:p>

</xml_diff>

<commit_message>
Quita la línea de soportes de la presentación
Co-Authored-By: Claude Opus 5.5 <noreply@anthropic.com>
Claude-Session: https://claude.ai/code/session_018mufWPZrGGp9c32gWXHPYT
</commit_message>
<xml_diff>
--- a/files/Accountability_TALENT.pptx
+++ b/files/Accountability_TALENT.pptx
@@ -119,19 +119,19 @@
   <p:extLst>
     <p:ext uri="{521415D9-36F7-43E2-AB2F-B90AF26B5E84}">
       <p14:sectionLst xmlns:p14="http://schemas.microsoft.com/office/powerpoint/2010/main">
-        <p14:section name="Equipo y unidad de análisis" id="{76418694-afcb-e236-adc2-96566602cfd8}">
+        <p14:section name="Equipo y unidad de análisis" id="{150fed17-f149-d73e-2727-46da3de9a332}">
           <p14:sldIdLst>
             <p14:sldId id="256"/>
             <p14:sldId id="257"/>
             <p14:sldId id="258"/>
           </p14:sldIdLst>
         </p14:section>
-        <p14:section name="Modelo de negocio" id="{5f54341f-8645-4461-bcf6-43e29ad494f5}">
+        <p14:section name="Modelo de negocio" id="{cef3cc55-b87a-6069-b2d3-393bb9015123}">
           <p14:sldIdLst>
             <p14:sldId id="259"/>
           </p14:sldIdLst>
         </p14:section>
-        <p14:section name="Diagnóstico" id="{39936f4b-0c25-3578-2168-e62d8ff34bd8}">
+        <p14:section name="Diagnóstico" id="{35f851ce-d7b8-42a6-5e2a-a552e97987c5}">
           <p14:sldIdLst>
             <p14:sldId id="260"/>
             <p14:sldId id="261"/>
@@ -139,7 +139,7 @@
             <p14:sldId id="263"/>
           </p14:sldIdLst>
         </p14:section>
-        <p14:section name="Ruta y alcance" id="{65493156-ece9-0086-52cd-bd885c56819b}">
+        <p14:section name="Ruta y alcance" id="{bd0534d5-7fc1-7636-55c8-48633f32df70}">
           <p14:sldIdLst>
             <p14:sldId id="264"/>
             <p14:sldId id="265"/>
@@ -8053,59 +8053,6 @@
               <a:t>Diana Salazar y Lina Cataño, sin conflicto de interés con el cliente</a:t>
             </a:r>
             <a:endParaRPr lang="en-US" sz="1400" dirty="0"/>
-          </a:p>
-        </p:txBody>
-      </p:sp>
-      <p:sp>
-        <p:nvSpPr>
-          <p:cNvPr id="16" name="Text 14"/>
-          <p:cNvSpPr txBox="1"/>
-          <p:nvPr/>
-        </p:nvSpPr>
-        <p:spPr>
-          <a:xfrm>
-            <a:off x="548640" y="5349240"/>
-            <a:ext cx="10972800" cy="457200"/>
-          </a:xfrm>
-          <a:prstGeom prst="rect">
-            <a:avLst/>
-          </a:prstGeom>
-          <a:noFill/>
-          <a:ln/>
-        </p:spPr>
-        <p:txBody>
-          <a:bodyPr wrap="square" lIns="0" tIns="0" rIns="0" bIns="0" rtlCol="0" anchor="t"/>
-          <a:lstStyle/>
-          <a:p>
-            <a:pPr indent="0" marL="0">
-              <a:buNone/>
-            </a:pPr>
-            <a:r>
-              <a:rPr lang="en-US" sz="1600" b="1" dirty="0">
-                <a:solidFill>
-                  <a:srgbClr val="E5D9C3"/>
-                </a:solidFill>
-                <a:latin typeface="Calibri" pitchFamily="34" charset="0"/>
-                <a:ea typeface="Calibri" pitchFamily="34" charset="-122"/>
-                <a:cs typeface="Calibri" pitchFamily="34" charset="-120"/>
-              </a:rPr>
-              <a:t>Soportes: </a:t>
-            </a:r>
-            <a:pPr indent="0" marL="0">
-              <a:buNone/>
-            </a:pPr>
-            <a:r>
-              <a:rPr lang="en-US" sz="1600" dirty="0">
-                <a:solidFill>
-                  <a:srgbClr val="D9D3C8"/>
-                </a:solidFill>
-                <a:latin typeface="Calibri" pitchFamily="34" charset="0"/>
-                <a:ea typeface="Calibri" pitchFamily="34" charset="-122"/>
-                <a:cs typeface="Calibri" pitchFamily="34" charset="-120"/>
-              </a:rPr>
-              <a:t>pantallazos de la reunión, acta firmada, consulta RUES, RUT, planilla PILA y licencia SST de la aliada.</a:t>
-            </a:r>
-            <a:endParaRPr lang="en-US" sz="1600" dirty="0"/>
           </a:p>
         </p:txBody>
       </p:sp>

</xml_diff>